<commit_message>
add repo link as kit url for hands-on activity
</commit_message>
<xml_diff>
--- a/Installation and Documentation Review Rehearsal-v2.pptx
+++ b/Installation and Documentation Review Rehearsal-v2.pptx
@@ -6139,7 +6139,7 @@
           <a:p>
             <a:pPr marL="0" indent="0" algn="l">
               <a:lnSpc>
-                <a:spcPts val="2160"/>
+                <a:spcPct val="100000"/>
               </a:lnSpc>
               <a:buNone/>
             </a:pPr>
@@ -6155,26 +6155,15 @@
               <a:t>Download the kit: </a:t>
             </a:r>
             <a:r>
-              <a:rPr lang="en-US" sz="1600" b="1" dirty="0">
-                <a:solidFill>
-                  <a:srgbClr val="1F1A24"/>
-                </a:solidFill>
-                <a:latin typeface="Lato" pitchFamily="34" charset="0"/>
-                <a:ea typeface="Lato" pitchFamily="34" charset="-122"/>
-                <a:cs typeface="Lato" pitchFamily="34" charset="-120"/>
-              </a:rPr>
-              <a:t>[kit link]</a:t>
-            </a:r>
-            <a:r>
-              <a:rPr lang="en-US" sz="1600" dirty="0">
-                <a:solidFill>
-                  <a:srgbClr val="1F1A24"/>
-                </a:solidFill>
-                <a:latin typeface="Lato" pitchFamily="34" charset="0"/>
-                <a:ea typeface="Lato" pitchFamily="34" charset="-122"/>
-                <a:cs typeface="Lato" pitchFamily="34" charset="-120"/>
-              </a:rPr>
-              <a:t> </a:t>
+              <a:rPr lang="en-US" sz="1600" u="sng" dirty="0">
+                <a:solidFill>
+                  <a:srgbClr val="0070C0"/>
+                </a:solidFill>
+                <a:latin typeface="Lato" pitchFamily="34" charset="0"/>
+                <a:ea typeface="Lato" pitchFamily="34" charset="-122"/>
+                <a:cs typeface="Lato" pitchFamily="34" charset="-120"/>
+              </a:rPr>
+              <a:t>https://github.com/sawyerb-ksu/heartland-ai-symposium-pi </a:t>
             </a:r>
             <a:r>
               <a:rPr lang="en-US" sz="1600" dirty="0">

</xml_diff>

<commit_message>
update mcp examples and add links for more resources
</commit_message>
<xml_diff>
--- a/Installation and Documentation Review Rehearsal-v2.pptx
+++ b/Installation and Documentation Review Rehearsal-v2.pptx
@@ -3348,14 +3348,16 @@
       </p:grpSpPr>
       <p:pic>
         <p:nvPicPr>
-          <p:cNvPr id="2" name="Image 0"/>
+          <p:cNvPr id="2" name="Image 0">
+            <a:hlinkClick r:id="rId3"/>
+          </p:cNvPr>
           <p:cNvPicPr>
             <a:picLocks noChangeAspect="1"/>
           </p:cNvPicPr>
           <p:nvPr/>
         </p:nvPicPr>
         <p:blipFill>
-          <a:blip r:embed="rId3"/>
+          <a:blip r:embed="rId4"/>
           <a:srcRect/>
           <a:stretch/>
         </p:blipFill>
@@ -3747,7 +3749,7 @@
               <a:buNone/>
             </a:pPr>
             <a:r>
-              <a:rPr lang="en-US" sz="1800" b="1" dirty="0">
+              <a:rPr lang="en-US" b="1" dirty="0">
                 <a:solidFill>
                   <a:srgbClr val="512888"/>
                 </a:solidFill>
@@ -3755,7 +3757,7 @@
                 <a:ea typeface="Lato" pitchFamily="34" charset="-122"/>
                 <a:cs typeface="Lato" pitchFamily="34" charset="-120"/>
               </a:rPr>
-              <a:t>Filesystem</a:t>
+              <a:t>Trust Me Bro</a:t>
             </a:r>
             <a:endParaRPr lang="en-US" sz="1800" dirty="0"/>
           </a:p>
@@ -3799,7 +3801,7 @@
                 <a:ea typeface="Lato" pitchFamily="34" charset="-122"/>
                 <a:cs typeface="Lato" pitchFamily="34" charset="-120"/>
               </a:rPr>
-              <a:t>Read and write files in folders you choose.</a:t>
+              <a:t>Validate information with cited sources are verified information.</a:t>
             </a:r>
             <a:endParaRPr lang="en-US" sz="1500" dirty="0"/>
           </a:p>
@@ -3843,7 +3845,7 @@
                 <a:ea typeface="Lato" pitchFamily="34" charset="-122"/>
                 <a:cs typeface="Lato" pitchFamily="34" charset="-120"/>
               </a:rPr>
-              <a:t>"Rename these scans by date."</a:t>
+              <a:t>“Validate the claims in this article."</a:t>
             </a:r>
             <a:endParaRPr lang="en-US" sz="1300" dirty="0"/>
           </a:p>
@@ -4275,7 +4277,29 @@
                 <a:ea typeface="Lato" pitchFamily="34" charset="-122"/>
                 <a:cs typeface="Lato" pitchFamily="34" charset="-120"/>
               </a:rPr>
-              <a:t>"Use the latest React Router API."</a:t>
+              <a:t>"Use the latest tools from </a:t>
+            </a:r>
+            <a:r>
+              <a:rPr lang="en-US" sz="1300" i="1" dirty="0" err="1">
+                <a:solidFill>
+                  <a:srgbClr val="5B5566"/>
+                </a:solidFill>
+                <a:latin typeface="Lato" pitchFamily="34" charset="0"/>
+                <a:ea typeface="Lato" pitchFamily="34" charset="-122"/>
+                <a:cs typeface="Lato" pitchFamily="34" charset="-120"/>
+              </a:rPr>
+              <a:t>pyzotero</a:t>
+            </a:r>
+            <a:r>
+              <a:rPr lang="en-US" sz="1300" i="1" dirty="0">
+                <a:solidFill>
+                  <a:srgbClr val="5B5566"/>
+                </a:solidFill>
+                <a:latin typeface="Lato" pitchFamily="34" charset="0"/>
+                <a:ea typeface="Lato" pitchFamily="34" charset="-122"/>
+                <a:cs typeface="Lato" pitchFamily="34" charset="-120"/>
+              </a:rPr>
+              <a:t>."</a:t>
             </a:r>
             <a:endParaRPr lang="en-US" sz="1300" dirty="0"/>
           </a:p>
@@ -4491,7 +4515,7 @@
                 <a:ea typeface="Lato" pitchFamily="34" charset="-122"/>
                 <a:cs typeface="Lato" pitchFamily="34" charset="-120"/>
               </a:rPr>
-              <a:t>"How do I register an Entra app?"</a:t>
+              <a:t>"How do I use Loop in Microsoft Teams?"</a:t>
             </a:r>
             <a:endParaRPr lang="en-US" sz="1300" dirty="0"/>
           </a:p>
@@ -4710,6 +4734,77 @@
               <a:t>"Add these notes to our project page."</a:t>
             </a:r>
             <a:endParaRPr lang="en-US" sz="1300" dirty="0"/>
+          </a:p>
+        </p:txBody>
+      </p:sp>
+      <p:sp>
+        <p:nvSpPr>
+          <p:cNvPr id="34" name="TextBox 33">
+            <a:extLst>
+              <a:ext uri="{FF2B5EF4-FFF2-40B4-BE49-F238E27FC236}">
+                <a16:creationId xmlns:a16="http://schemas.microsoft.com/office/drawing/2014/main" id="{E809A115-7839-A4CB-6C92-56C6502D7961}"/>
+              </a:ext>
+            </a:extLst>
+          </p:cNvPr>
+          <p:cNvSpPr txBox="1"/>
+          <p:nvPr/>
+        </p:nvSpPr>
+        <p:spPr>
+          <a:xfrm>
+            <a:off x="914400" y="5267958"/>
+            <a:ext cx="10355541" cy="338554"/>
+          </a:xfrm>
+          <a:prstGeom prst="rect">
+            <a:avLst/>
+          </a:prstGeom>
+          <a:noFill/>
+        </p:spPr>
+        <p:txBody>
+          <a:bodyPr wrap="square" rtlCol="0">
+            <a:spAutoFit/>
+          </a:bodyPr>
+          <a:lstStyle/>
+          <a:p>
+            <a:r>
+              <a:rPr lang="en-US" sz="1600" dirty="0">
+                <a:solidFill>
+                  <a:srgbClr val="1F1A24"/>
+                </a:solidFill>
+                <a:latin typeface="Lato" pitchFamily="34" charset="0"/>
+                <a:ea typeface="Lato" pitchFamily="34" charset="-122"/>
+                <a:cs typeface="Lato" pitchFamily="34" charset="-120"/>
+              </a:rPr>
+              <a:t>Check out </a:t>
+            </a:r>
+            <a:r>
+              <a:rPr lang="en-US" sz="1600" dirty="0">
+                <a:solidFill>
+                  <a:srgbClr val="1F1A24"/>
+                </a:solidFill>
+                <a:latin typeface="Lato" pitchFamily="34" charset="0"/>
+                <a:ea typeface="Lato" pitchFamily="34" charset="-122"/>
+                <a:cs typeface="Lato" pitchFamily="34" charset="-120"/>
+                <a:hlinkClick r:id="rId3">
+                  <a:extLst>
+                    <a:ext uri="{A12FA001-AC4F-418D-AE19-62706E023703}">
+                      <ahyp:hlinkClr xmlns:ahyp="http://schemas.microsoft.com/office/drawing/2018/hyperlinkcolor" val="tx"/>
+                    </a:ext>
+                  </a:extLst>
+                </a:hlinkClick>
+              </a:rPr>
+              <a:t>https://mcpservers.org/</a:t>
+            </a:r>
+            <a:r>
+              <a:rPr lang="en-US" sz="1600" dirty="0">
+                <a:solidFill>
+                  <a:srgbClr val="1F1A24"/>
+                </a:solidFill>
+                <a:latin typeface="Lato" pitchFamily="34" charset="0"/>
+                <a:ea typeface="Lato" pitchFamily="34" charset="-122"/>
+                <a:cs typeface="Lato" pitchFamily="34" charset="-120"/>
+              </a:rPr>
+              <a:t> to find tools that work best for you.</a:t>
+            </a:r>
           </a:p>
         </p:txBody>
       </p:sp>
@@ -11604,7 +11699,7 @@
                 <a:ea typeface="Lato" pitchFamily="34" charset="-122"/>
                 <a:cs typeface="Lato" pitchFamily="34" charset="-120"/>
               </a:rPr>
-              <a:t>C:\Users\username\.pi\agent</a:t>
+              <a:t>C:\Users\YOUR_USER\.pi\agent</a:t>
             </a:r>
             <a:endParaRPr lang="en-US" sz="1600" dirty="0"/>
           </a:p>
@@ -14031,6 +14126,59 @@
               <a:t>pi -e ./my-extension.ts</a:t>
             </a:r>
             <a:endParaRPr lang="en-US" sz="1300" dirty="0"/>
+          </a:p>
+        </p:txBody>
+      </p:sp>
+      <p:sp>
+        <p:nvSpPr>
+          <p:cNvPr id="11" name="TextBox 10">
+            <a:extLst>
+              <a:ext uri="{FF2B5EF4-FFF2-40B4-BE49-F238E27FC236}">
+                <a16:creationId xmlns:a16="http://schemas.microsoft.com/office/drawing/2014/main" id="{7273AE03-6033-6487-E5B3-101A10D57258}"/>
+              </a:ext>
+            </a:extLst>
+          </p:cNvPr>
+          <p:cNvSpPr txBox="1"/>
+          <p:nvPr/>
+        </p:nvSpPr>
+        <p:spPr>
+          <a:xfrm>
+            <a:off x="914400" y="5189460"/>
+            <a:ext cx="10363200" cy="338554"/>
+          </a:xfrm>
+          <a:prstGeom prst="rect">
+            <a:avLst/>
+          </a:prstGeom>
+          <a:noFill/>
+        </p:spPr>
+        <p:txBody>
+          <a:bodyPr wrap="square" rtlCol="0">
+            <a:spAutoFit/>
+          </a:bodyPr>
+          <a:lstStyle/>
+          <a:p>
+            <a:r>
+              <a:rPr lang="en-US" sz="1600" dirty="0">
+                <a:solidFill>
+                  <a:srgbClr val="1F1A24"/>
+                </a:solidFill>
+                <a:latin typeface="Lato" pitchFamily="34" charset="0"/>
+                <a:ea typeface="Lato" pitchFamily="34" charset="-122"/>
+                <a:cs typeface="Lato" pitchFamily="34" charset="-120"/>
+              </a:rPr>
+              <a:t>Browse community developed extensions for Pi at: </a:t>
+            </a:r>
+            <a:r>
+              <a:rPr lang="en-US" sz="1600" u="sng" dirty="0">
+                <a:solidFill>
+                  <a:srgbClr val="1F1A24"/>
+                </a:solidFill>
+                <a:latin typeface="Lato" pitchFamily="34" charset="0"/>
+                <a:ea typeface="Lato" pitchFamily="34" charset="-122"/>
+                <a:cs typeface="Lato" pitchFamily="34" charset="-120"/>
+              </a:rPr>
+              <a:t>https://pi.dev/packages</a:t>
+            </a:r>
           </a:p>
         </p:txBody>
       </p:sp>

</xml_diff>